<commit_message>
Add day 1 materials
</commit_message>
<xml_diff>
--- a/заняття_1/python_lesson1.pptx
+++ b/заняття_1/python_lesson1.pptx
@@ -2325,7 +2325,7 @@
               <a:buNone/>
             </a:pPr>
             <a:r>
-              <a:rPr lang="en-US" sz="5200" b="1" dirty="0">
+              <a:rPr lang="en-US" sz="5200" b="1" dirty="0" err="1">
                 <a:solidFill>
                   <a:srgbClr val="E8EEFE"/>
                 </a:solidFill>
@@ -2333,7 +2333,18 @@
                 <a:ea typeface="Trebuchet MS" pitchFamily="34" charset="-122"/>
                 <a:cs typeface="Trebuchet MS" pitchFamily="34" charset="-120"/>
               </a:rPr>
-              <a:t>Заняття 1</a:t>
+              <a:t>Заняття</a:t>
+            </a:r>
+            <a:r>
+              <a:rPr lang="en-US" sz="5200" b="1" dirty="0">
+                <a:solidFill>
+                  <a:srgbClr val="E8EEFE"/>
+                </a:solidFill>
+                <a:latin typeface="Trebuchet MS" pitchFamily="34" charset="0"/>
+                <a:ea typeface="Trebuchet MS" pitchFamily="34" charset="-122"/>
+                <a:cs typeface="Trebuchet MS" pitchFamily="34" charset="-120"/>
+              </a:rPr>
+              <a:t> 1</a:t>
             </a:r>
             <a:endParaRPr lang="en-US" sz="5200" dirty="0"/>
           </a:p>
@@ -9915,8 +9926,8 @@
         </p:nvSpPr>
         <p:spPr>
           <a:xfrm>
-            <a:off x="457200" y="1143000"/>
-            <a:ext cx="8229600" cy="960120"/>
+            <a:off x="457200" y="1348740"/>
+            <a:ext cx="8229600" cy="790956"/>
           </a:xfrm>
           <a:prstGeom prst="rect">
             <a:avLst/>
@@ -9949,7 +9960,7 @@
         </p:nvSpPr>
         <p:spPr>
           <a:xfrm>
-            <a:off x="640080" y="1314306"/>
+            <a:off x="640080" y="1465182"/>
             <a:ext cx="640080" cy="640080"/>
           </a:xfrm>
           <a:prstGeom prst="rect">
@@ -9985,7 +9996,7 @@
         </p:nvSpPr>
         <p:spPr>
           <a:xfrm>
-            <a:off x="1417320" y="1234440"/>
+            <a:off x="1417320" y="1385316"/>
             <a:ext cx="6949440" cy="685800"/>
           </a:xfrm>
           <a:prstGeom prst="rect">
@@ -10025,7 +10036,7 @@
         <p:spPr>
           <a:xfrm>
             <a:off x="457200" y="2286000"/>
-            <a:ext cx="8229600" cy="960120"/>
+            <a:ext cx="8229600" cy="853653"/>
           </a:xfrm>
           <a:prstGeom prst="rect">
             <a:avLst/>
@@ -10133,8 +10144,8 @@
         </p:nvSpPr>
         <p:spPr>
           <a:xfrm>
-            <a:off x="457200" y="3429000"/>
-            <a:ext cx="8229600" cy="960120"/>
+            <a:off x="457200" y="3299673"/>
+            <a:ext cx="8229600" cy="708660"/>
           </a:xfrm>
           <a:prstGeom prst="rect">
             <a:avLst/>
@@ -10167,7 +10178,7 @@
         </p:nvSpPr>
         <p:spPr>
           <a:xfrm>
-            <a:off x="617220" y="3589020"/>
+            <a:off x="617220" y="3368253"/>
             <a:ext cx="640080" cy="640080"/>
           </a:xfrm>
           <a:prstGeom prst="rect">
@@ -10203,7 +10214,7 @@
         </p:nvSpPr>
         <p:spPr>
           <a:xfrm>
-            <a:off x="1417320" y="3520440"/>
+            <a:off x="1417320" y="3299673"/>
             <a:ext cx="6949440" cy="685800"/>
           </a:xfrm>
           <a:prstGeom prst="rect">
@@ -10264,7 +10275,7 @@
         </p:nvSpPr>
         <p:spPr>
           <a:xfrm>
-            <a:off x="457200" y="4526280"/>
+            <a:off x="457200" y="4439412"/>
             <a:ext cx="8229600" cy="502920"/>
           </a:xfrm>
           <a:prstGeom prst="rect">
@@ -10296,7 +10307,7 @@
         </p:nvSpPr>
         <p:spPr>
           <a:xfrm>
-            <a:off x="548640" y="4526280"/>
+            <a:off x="548640" y="4439412"/>
             <a:ext cx="8046720" cy="502920"/>
           </a:xfrm>
           <a:prstGeom prst="rect">
@@ -10439,7 +10450,7 @@
         </p:nvSpPr>
         <p:spPr>
           <a:xfrm>
-            <a:off x="365760" y="1005840"/>
+            <a:off x="372155" y="1082573"/>
             <a:ext cx="2651760" cy="1645920"/>
           </a:xfrm>
           <a:prstGeom prst="rect">
@@ -10473,7 +10484,7 @@
         </p:nvSpPr>
         <p:spPr>
           <a:xfrm>
-            <a:off x="365760" y="1005840"/>
+            <a:off x="372155" y="1082573"/>
             <a:ext cx="2651760" cy="82296"/>
           </a:xfrm>
           <a:prstGeom prst="rect">
@@ -10505,7 +10516,7 @@
         </p:nvSpPr>
         <p:spPr>
           <a:xfrm>
-            <a:off x="365760" y="1229868"/>
+            <a:off x="372155" y="1306601"/>
             <a:ext cx="2651760" cy="548640"/>
           </a:xfrm>
           <a:prstGeom prst="rect">
@@ -10541,7 +10552,7 @@
         </p:nvSpPr>
         <p:spPr>
           <a:xfrm>
-            <a:off x="365760" y="1664208"/>
+            <a:off x="372155" y="1740941"/>
             <a:ext cx="2651760" cy="411480"/>
           </a:xfrm>
           <a:prstGeom prst="rect">
@@ -10580,7 +10591,7 @@
         </p:nvSpPr>
         <p:spPr>
           <a:xfrm>
-            <a:off x="365760" y="2048256"/>
+            <a:off x="372155" y="2124989"/>
             <a:ext cx="2651760" cy="411480"/>
           </a:xfrm>
           <a:prstGeom prst="rect">
@@ -10619,7 +10630,7 @@
         </p:nvSpPr>
         <p:spPr>
           <a:xfrm>
-            <a:off x="3246120" y="1005840"/>
+            <a:off x="3252515" y="1082573"/>
             <a:ext cx="2651760" cy="1645920"/>
           </a:xfrm>
           <a:prstGeom prst="rect">
@@ -10653,7 +10664,7 @@
         </p:nvSpPr>
         <p:spPr>
           <a:xfrm>
-            <a:off x="3246120" y="1005840"/>
+            <a:off x="3252515" y="1082573"/>
             <a:ext cx="2651760" cy="82296"/>
           </a:xfrm>
           <a:prstGeom prst="rect">
@@ -10685,7 +10696,7 @@
         </p:nvSpPr>
         <p:spPr>
           <a:xfrm>
-            <a:off x="3246120" y="1229868"/>
+            <a:off x="3252515" y="1306601"/>
             <a:ext cx="2651760" cy="548640"/>
           </a:xfrm>
           <a:prstGeom prst="rect">
@@ -10721,7 +10732,7 @@
         </p:nvSpPr>
         <p:spPr>
           <a:xfrm>
-            <a:off x="3246120" y="1664208"/>
+            <a:off x="3252515" y="1740941"/>
             <a:ext cx="2651760" cy="411480"/>
           </a:xfrm>
           <a:prstGeom prst="rect">
@@ -10760,7 +10771,7 @@
         </p:nvSpPr>
         <p:spPr>
           <a:xfrm>
-            <a:off x="3246120" y="2048256"/>
+            <a:off x="3252515" y="2124989"/>
             <a:ext cx="2651760" cy="411480"/>
           </a:xfrm>
           <a:prstGeom prst="rect">
@@ -10799,7 +10810,7 @@
         </p:nvSpPr>
         <p:spPr>
           <a:xfrm>
-            <a:off x="6126480" y="1005840"/>
+            <a:off x="6132875" y="1082573"/>
             <a:ext cx="2651760" cy="1645920"/>
           </a:xfrm>
           <a:prstGeom prst="rect">
@@ -10833,7 +10844,7 @@
         </p:nvSpPr>
         <p:spPr>
           <a:xfrm>
-            <a:off x="6126480" y="1005840"/>
+            <a:off x="6132875" y="1082573"/>
             <a:ext cx="2651760" cy="82296"/>
           </a:xfrm>
           <a:prstGeom prst="rect">
@@ -10865,7 +10876,7 @@
         </p:nvSpPr>
         <p:spPr>
           <a:xfrm>
-            <a:off x="6126480" y="1229868"/>
+            <a:off x="6132875" y="1306601"/>
             <a:ext cx="2651760" cy="548640"/>
           </a:xfrm>
           <a:prstGeom prst="rect">
@@ -10901,7 +10912,7 @@
         </p:nvSpPr>
         <p:spPr>
           <a:xfrm>
-            <a:off x="6126480" y="1664208"/>
+            <a:off x="6132875" y="1740941"/>
             <a:ext cx="2651760" cy="411480"/>
           </a:xfrm>
           <a:prstGeom prst="rect">
@@ -10940,7 +10951,7 @@
         </p:nvSpPr>
         <p:spPr>
           <a:xfrm>
-            <a:off x="6126480" y="2048256"/>
+            <a:off x="6132875" y="2124989"/>
             <a:ext cx="2651760" cy="411480"/>
           </a:xfrm>
           <a:prstGeom prst="rect">
@@ -10979,7 +10990,7 @@
         </p:nvSpPr>
         <p:spPr>
           <a:xfrm>
-            <a:off x="365760" y="2880360"/>
+            <a:off x="372155" y="2957093"/>
             <a:ext cx="2651760" cy="1645920"/>
           </a:xfrm>
           <a:prstGeom prst="rect">
@@ -11013,7 +11024,7 @@
         </p:nvSpPr>
         <p:spPr>
           <a:xfrm>
-            <a:off x="365760" y="2880360"/>
+            <a:off x="372155" y="2957093"/>
             <a:ext cx="2651760" cy="82296"/>
           </a:xfrm>
           <a:prstGeom prst="rect">
@@ -11045,7 +11056,7 @@
         </p:nvSpPr>
         <p:spPr>
           <a:xfrm>
-            <a:off x="365760" y="3086100"/>
+            <a:off x="372155" y="3162833"/>
             <a:ext cx="2651760" cy="548640"/>
           </a:xfrm>
           <a:prstGeom prst="rect">
@@ -11081,7 +11092,7 @@
         </p:nvSpPr>
         <p:spPr>
           <a:xfrm>
-            <a:off x="365760" y="3538728"/>
+            <a:off x="372155" y="3615461"/>
             <a:ext cx="2651760" cy="411480"/>
           </a:xfrm>
           <a:prstGeom prst="rect">
@@ -11120,7 +11131,7 @@
         </p:nvSpPr>
         <p:spPr>
           <a:xfrm>
-            <a:off x="365760" y="3922776"/>
+            <a:off x="372155" y="3999509"/>
             <a:ext cx="2651760" cy="411480"/>
           </a:xfrm>
           <a:prstGeom prst="rect">
@@ -11159,7 +11170,7 @@
         </p:nvSpPr>
         <p:spPr>
           <a:xfrm>
-            <a:off x="3246120" y="2880360"/>
+            <a:off x="3252515" y="2957093"/>
             <a:ext cx="2651760" cy="1645920"/>
           </a:xfrm>
           <a:prstGeom prst="rect">
@@ -11193,7 +11204,7 @@
         </p:nvSpPr>
         <p:spPr>
           <a:xfrm>
-            <a:off x="3246120" y="2880360"/>
+            <a:off x="3252515" y="2957093"/>
             <a:ext cx="2651760" cy="82296"/>
           </a:xfrm>
           <a:prstGeom prst="rect">
@@ -11225,7 +11236,7 @@
         </p:nvSpPr>
         <p:spPr>
           <a:xfrm>
-            <a:off x="3246120" y="3091855"/>
+            <a:off x="3252515" y="3168588"/>
             <a:ext cx="2651760" cy="548640"/>
           </a:xfrm>
           <a:prstGeom prst="rect">
@@ -11261,7 +11272,7 @@
         </p:nvSpPr>
         <p:spPr>
           <a:xfrm>
-            <a:off x="3246120" y="3538728"/>
+            <a:off x="3252515" y="3615461"/>
             <a:ext cx="2651760" cy="411480"/>
           </a:xfrm>
           <a:prstGeom prst="rect">
@@ -11300,7 +11311,7 @@
         </p:nvSpPr>
         <p:spPr>
           <a:xfrm>
-            <a:off x="3246120" y="3922776"/>
+            <a:off x="3252515" y="3999509"/>
             <a:ext cx="2651760" cy="411480"/>
           </a:xfrm>
           <a:prstGeom prst="rect">
@@ -11339,7 +11350,7 @@
         </p:nvSpPr>
         <p:spPr>
           <a:xfrm>
-            <a:off x="6126480" y="2880360"/>
+            <a:off x="6132875" y="2957093"/>
             <a:ext cx="2651760" cy="1645920"/>
           </a:xfrm>
           <a:prstGeom prst="rect">
@@ -11373,7 +11384,7 @@
         </p:nvSpPr>
         <p:spPr>
           <a:xfrm>
-            <a:off x="6126480" y="2880360"/>
+            <a:off x="6132875" y="2957093"/>
             <a:ext cx="2651760" cy="82296"/>
           </a:xfrm>
           <a:prstGeom prst="rect">
@@ -11405,7 +11416,7 @@
         </p:nvSpPr>
         <p:spPr>
           <a:xfrm>
-            <a:off x="6126480" y="3086100"/>
+            <a:off x="6132875" y="3162833"/>
             <a:ext cx="2651760" cy="548640"/>
           </a:xfrm>
           <a:prstGeom prst="rect">
@@ -11441,7 +11452,7 @@
         </p:nvSpPr>
         <p:spPr>
           <a:xfrm>
-            <a:off x="6126480" y="3538728"/>
+            <a:off x="6132875" y="3615461"/>
             <a:ext cx="2651760" cy="411480"/>
           </a:xfrm>
           <a:prstGeom prst="rect">
@@ -11480,7 +11491,7 @@
         </p:nvSpPr>
         <p:spPr>
           <a:xfrm>
-            <a:off x="6126480" y="3922776"/>
+            <a:off x="6132875" y="3999509"/>
             <a:ext cx="2651760" cy="411480"/>
           </a:xfrm>
           <a:prstGeom prst="rect">

</xml_diff>

<commit_message>
Update day 3 materials
</commit_message>
<xml_diff>
--- a/заняття_1/python_lesson1.pptx
+++ b/заняття_1/python_lesson1.pptx
@@ -2325,7 +2325,7 @@
               <a:buNone/>
             </a:pPr>
             <a:r>
-              <a:rPr lang="en-US" sz="5200" b="1" dirty="0" err="1">
+              <a:rPr lang="en-US" sz="5200" b="1" dirty="0">
                 <a:solidFill>
                   <a:srgbClr val="E8EEFE"/>
                 </a:solidFill>
@@ -2333,18 +2333,7 @@
                 <a:ea typeface="Trebuchet MS" pitchFamily="34" charset="-122"/>
                 <a:cs typeface="Trebuchet MS" pitchFamily="34" charset="-120"/>
               </a:rPr>
-              <a:t>Заняття</a:t>
-            </a:r>
-            <a:r>
-              <a:rPr lang="en-US" sz="5200" b="1" dirty="0">
-                <a:solidFill>
-                  <a:srgbClr val="E8EEFE"/>
-                </a:solidFill>
-                <a:latin typeface="Trebuchet MS" pitchFamily="34" charset="0"/>
-                <a:ea typeface="Trebuchet MS" pitchFamily="34" charset="-122"/>
-                <a:cs typeface="Trebuchet MS" pitchFamily="34" charset="-120"/>
-              </a:rPr>
-              <a:t> 1</a:t>
+              <a:t>Заняття 1</a:t>
             </a:r>
             <a:endParaRPr lang="en-US" sz="5200" dirty="0"/>
           </a:p>

</xml_diff>